<commit_message>
Logo Polmedi w kontrze na okladce prezentacji HiRS
Okladka ma tlo granatowe, wiec znak pelnokolorowy stal na bialym prostokacie
i wygladal jak naklejka. Teraz idzie tam wersja biala, wprost na tle.

Do PPTX potrzebny jest PNG, bo python-pptx nie przyjmuje SVG. Rasteryzuje go
`makiety_png.py` Edge'em z `--default-background-color=00000000` — znak jest bialy,
wiec na domyslnym bialym tle wyszlaby biel na bieli. Sprawdzone: 100% pikseli
nieprzezroczystych jest biale, tlo ma alfa 0.

Bez tego pliku okladka wraca do poprzedniego wygladu, wiec brak rasteryzacji niczego
nie wywraca.

Co-Authored-By: Claude Opus 5 <noreply@anthropic.com>
</commit_message>
<xml_diff>
--- a/docs/prezentacja-hirs/HiRS-prezentacja.pptx
+++ b/docs/prezentacja-hirs/HiRS-prezentacja.pptx
@@ -4361,55 +4361,9 @@
           </a:p>
         </p:txBody>
       </p:sp>
-      <p:sp>
-        <p:nvSpPr>
-          <p:cNvPr id="8" name="Rounded Rectangle 7"/>
-          <p:cNvSpPr/>
-          <p:nvPr/>
-        </p:nvSpPr>
-        <p:spPr>
-          <a:xfrm>
-            <a:off x="10134600" y="6057900"/>
-            <a:ext cx="1447800" cy="457200"/>
-          </a:xfrm>
-          <a:prstGeom prst="roundRect">
-            <a:avLst>
-              <a:gd name="adj" fmla="val 6000"/>
-            </a:avLst>
-          </a:prstGeom>
-          <a:solidFill>
-            <a:srgbClr val="FFFFFF"/>
-          </a:solidFill>
-          <a:ln>
-            <a:noFill/>
-          </a:ln>
-          <a:effectLst/>
-        </p:spPr>
-        <p:style>
-          <a:lnRef idx="1">
-            <a:schemeClr val="accent1"/>
-          </a:lnRef>
-          <a:fillRef idx="3">
-            <a:schemeClr val="accent1"/>
-          </a:fillRef>
-          <a:effectRef idx="2">
-            <a:schemeClr val="accent1"/>
-          </a:effectRef>
-          <a:fontRef idx="minor">
-            <a:schemeClr val="lt1"/>
-          </a:fontRef>
-        </p:style>
-        <p:txBody>
-          <a:bodyPr rtlCol="0" anchor="ctr" wrap="square"/>
-          <a:lstStyle/>
-          <a:p>
-            <a:pPr algn="ctr"/>
-          </a:p>
-        </p:txBody>
-      </p:sp>
       <p:pic>
         <p:nvPicPr>
-          <p:cNvPr id="9" name="Picture 8" descr="polmedi-group.png"/>
+          <p:cNvPr id="8" name="Picture 7" descr="polmedi-group-white.png"/>
           <p:cNvPicPr>
             <a:picLocks noChangeAspect="1"/>
           </p:cNvPicPr>
@@ -4423,8 +4377,8 @@
         </p:blipFill>
         <p:spPr>
           <a:xfrm>
-            <a:off x="10287000" y="6153150"/>
-            <a:ext cx="1143000" cy="381000"/>
+            <a:off x="9610725" y="6000750"/>
+            <a:ext cx="1971675" cy="438698"/>
           </a:xfrm>
           <a:prstGeom prst="rect">
             <a:avLst/>

</xml_diff>